<commit_message>
Final: Replaced Streamlit with Custom Flask/HTML Dashboard, updated reports & README
</commit_message>
<xml_diff>
--- a/Bluestock_MF_Presentation.pptx
+++ b/Bluestock_MF_Presentation.pptx
@@ -3274,7 +3274,7 @@
                 </a:solidFill>
                 <a:latin typeface="Arial"/>
               </a:rPr>
-              <a:t>Premium Interactive Streamlit Web App</a:t>
+              <a:t>Premium Interactive Web Dashboard</a:t>
             </a:r>
           </a:p>
         </p:txBody>
@@ -3295,7 +3295,7 @@
           <a:lstStyle/>
           <a:p>
             <a:r>
-              <a:t>A full web app (dashboard/app.py) engineered to replace static slides:</a:t>
+              <a:t>A custom-engineered Single Page Web App (dashboard/server.py + index.html) with Chart.js visualization:</a:t>
             </a:r>
           </a:p>
           <a:p>
@@ -3586,7 +3586,7 @@
             </a:r>
             <a:br/>
             <a:r>
-              <a:t>4. Deploy Streamlit interactive web application and schedule weekday ETL fetches.</a:t>
+              <a:t>4. Deploy Custom Flask &amp; HTML/JS/CSS interactive web application and schedule weekday ETL fetches.</a:t>
             </a:r>
           </a:p>
         </p:txBody>

</xml_diff>